<commit_message>
Implement config-driven BoI workflow PoC
</commit_message>
<xml_diff>
--- a/artifacts/boi-poc/boi-wiki-poc-executive-brief.pptx
+++ b/artifacts/boi-poc/boi-wiki-poc-executive-brief.pptx
@@ -13981,7 +13981,7 @@
                 </a:solidFill>
                 <a:latin typeface="Malgun Gothic"/>
               </a:rPr>
-              <a:t>15</a:t>
+              <a:t>21</a:t>
             </a:r>
           </a:p>
         </p:txBody>
@@ -14096,7 +14096,7 @@
                 </a:solidFill>
                 <a:latin typeface="Malgun Gothic"/>
               </a:rPr>
-              <a:t>60</a:t>
+              <a:t>144</a:t>
             </a:r>
           </a:p>
         </p:txBody>
@@ -14211,7 +14211,7 @@
                 </a:solidFill>
                 <a:latin typeface="Malgun Gothic"/>
               </a:rPr>
-              <a:t>48</a:t>
+              <a:t>122</a:t>
             </a:r>
           </a:p>
         </p:txBody>
@@ -14326,7 +14326,7 @@
                 </a:solidFill>
                 <a:latin typeface="Malgun Gothic"/>
               </a:rPr>
-              <a:t>10</a:t>
+              <a:t>95</a:t>
             </a:r>
           </a:p>
         </p:txBody>
@@ -15355,7 +15355,7 @@
                 </a:solidFill>
                 <a:latin typeface="Malgun Gothic"/>
               </a:rPr>
-              <a:t>Langflow Flow</a:t>
+              <a:t>Event Trace에서 호출된 Flow</a:t>
             </a:r>
           </a:p>
         </p:txBody>
@@ -15389,11 +15389,11 @@
                 </a:solidFill>
                 <a:latin typeface="Malgun Gothic"/>
               </a:rPr>
-              <a:t>BoI Reference Flow (2)</a:t>
+              <a:t>BoI Reference Flow (15)</a:t>
             </a:r>
             <a:br/>
             <a:r>
-              <a:t>15b0199d-583a-4b2e-b692-3ec1744a7c75</a:t>
+              <a:t>3aba3309-89a8-4171-a153-00db6b16dcba</a:t>
             </a:r>
           </a:p>
         </p:txBody>
@@ -15406,8 +15406,8 @@
         </p:nvSpPr>
         <p:spPr>
           <a:xfrm>
-            <a:off x="822960" y="3657600"/>
-            <a:ext cx="10195560" cy="1508760"/>
+            <a:off x="822960" y="3337560"/>
+            <a:ext cx="4937760" cy="1143000"/>
           </a:xfrm>
           <a:prstGeom prst="roundRect">
             <a:avLst/>
@@ -15451,8 +15451,172 @@
         </p:nvSpPr>
         <p:spPr>
           <a:xfrm>
-            <a:off x="822960" y="3657600"/>
-            <a:ext cx="73152" cy="1508760"/>
+            <a:off x="822960" y="3337560"/>
+            <a:ext cx="73152" cy="1143000"/>
+          </a:xfrm>
+          <a:prstGeom prst="rect">
+            <a:avLst/>
+          </a:prstGeom>
+          <a:solidFill>
+            <a:srgbClr val="1F61FF"/>
+          </a:solidFill>
+          <a:ln>
+            <a:noFill/>
+          </a:ln>
+        </p:spPr>
+        <p:style>
+          <a:lnRef idx="1">
+            <a:schemeClr val="accent1"/>
+          </a:lnRef>
+          <a:fillRef idx="3">
+            <a:schemeClr val="accent1"/>
+          </a:fillRef>
+          <a:effectRef idx="2">
+            <a:schemeClr val="accent1"/>
+          </a:effectRef>
+          <a:fontRef idx="minor">
+            <a:schemeClr val="lt1"/>
+          </a:fontRef>
+        </p:style>
+        <p:txBody>
+          <a:bodyPr rtlCol="0" anchor="ctr"/>
+          <a:lstStyle/>
+          <a:p>
+            <a:pPr algn="ctr"/>
+          </a:p>
+        </p:txBody>
+      </p:sp>
+      <p:sp>
+        <p:nvSpPr>
+          <p:cNvPr id="16" name="TextBox 15"/>
+          <p:cNvSpPr txBox="1"/>
+          <p:nvPr/>
+        </p:nvSpPr>
+        <p:spPr>
+          <a:xfrm>
+            <a:off x="987552" y="3465576"/>
+            <a:ext cx="4626864" cy="274320"/>
+          </a:xfrm>
+          <a:prstGeom prst="rect">
+            <a:avLst/>
+          </a:prstGeom>
+          <a:noFill/>
+        </p:spPr>
+        <p:txBody>
+          <a:bodyPr wrap="square">
+            <a:spAutoFit/>
+          </a:bodyPr>
+          <a:lstStyle/>
+          <a:p>
+            <a:r>
+              <a:rPr sz="1300" b="1">
+                <a:solidFill>
+                  <a:srgbClr val="0F1F34"/>
+                </a:solidFill>
+                <a:latin typeface="Malgun Gothic"/>
+              </a:rPr>
+              <a:t>E2E Action Log</a:t>
+            </a:r>
+          </a:p>
+        </p:txBody>
+      </p:sp>
+      <p:sp>
+        <p:nvSpPr>
+          <p:cNvPr id="17" name="TextBox 16"/>
+          <p:cNvSpPr txBox="1"/>
+          <p:nvPr/>
+        </p:nvSpPr>
+        <p:spPr>
+          <a:xfrm>
+            <a:off x="987552" y="3840480"/>
+            <a:ext cx="4626864" cy="539496"/>
+          </a:xfrm>
+          <a:prstGeom prst="rect">
+            <a:avLst/>
+          </a:prstGeom>
+          <a:noFill/>
+        </p:spPr>
+        <p:txBody>
+          <a:bodyPr wrap="square">
+            <a:spAutoFit/>
+          </a:bodyPr>
+          <a:lstStyle/>
+          <a:p>
+            <a:r>
+              <a:rPr sz="950" b="0">
+                <a:solidFill>
+                  <a:srgbClr val="1C2128"/>
+                </a:solidFill>
+                <a:latin typeface="Malgun Gothic"/>
+              </a:rPr>
+              <a:t>trace=trace-492cf5507241492abd6a7160ad14d1d5</a:t>
+            </a:r>
+            <a:br/>
+            <a:r>
+              <a:t>event=equipment.alarm.raised.v1</a:t>
+            </a:r>
+            <a:br/>
+            <a:r>
+              <a:t>status=langflow_invoked</a:t>
+            </a:r>
+          </a:p>
+        </p:txBody>
+      </p:sp>
+      <p:sp>
+        <p:nvSpPr>
+          <p:cNvPr id="18" name="Rounded Rectangle 17"/>
+          <p:cNvSpPr/>
+          <p:nvPr/>
+        </p:nvSpPr>
+        <p:spPr>
+          <a:xfrm>
+            <a:off x="6080760" y="3337560"/>
+            <a:ext cx="4937760" cy="1143000"/>
+          </a:xfrm>
+          <a:prstGeom prst="roundRect">
+            <a:avLst/>
+          </a:prstGeom>
+          <a:solidFill>
+            <a:srgbClr val="FFFFFF"/>
+          </a:solidFill>
+          <a:ln>
+            <a:solidFill>
+              <a:srgbClr val="DBE2EC"/>
+            </a:solidFill>
+          </a:ln>
+        </p:spPr>
+        <p:style>
+          <a:lnRef idx="1">
+            <a:schemeClr val="accent1"/>
+          </a:lnRef>
+          <a:fillRef idx="3">
+            <a:schemeClr val="accent1"/>
+          </a:fillRef>
+          <a:effectRef idx="2">
+            <a:schemeClr val="accent1"/>
+          </a:effectRef>
+          <a:fontRef idx="minor">
+            <a:schemeClr val="lt1"/>
+          </a:fontRef>
+        </p:style>
+        <p:txBody>
+          <a:bodyPr rtlCol="0" anchor="ctr"/>
+          <a:lstStyle/>
+          <a:p>
+            <a:pPr algn="ctr"/>
+          </a:p>
+        </p:txBody>
+      </p:sp>
+      <p:sp>
+        <p:nvSpPr>
+          <p:cNvPr id="19" name="Rectangle 18"/>
+          <p:cNvSpPr/>
+          <p:nvPr/>
+        </p:nvSpPr>
+        <p:spPr>
+          <a:xfrm>
+            <a:off x="6080760" y="3337560"/>
+            <a:ext cx="73152" cy="1143000"/>
           </a:xfrm>
           <a:prstGeom prst="rect">
             <a:avLst/>
@@ -15488,14 +15652,14 @@
       </p:sp>
       <p:sp>
         <p:nvSpPr>
-          <p:cNvPr id="16" name="TextBox 15"/>
-          <p:cNvSpPr txBox="1"/>
-          <p:nvPr/>
-        </p:nvSpPr>
-        <p:spPr>
-          <a:xfrm>
-            <a:off x="987552" y="3785615"/>
-            <a:ext cx="9884664" cy="274320"/>
+          <p:cNvPr id="20" name="TextBox 19"/>
+          <p:cNvSpPr txBox="1"/>
+          <p:nvPr/>
+        </p:nvSpPr>
+        <p:spPr>
+          <a:xfrm>
+            <a:off x="6245352" y="3465576"/>
+            <a:ext cx="4626864" cy="274320"/>
           </a:xfrm>
           <a:prstGeom prst="rect">
             <a:avLst/>
@@ -15515,58 +15679,67 @@
                 </a:solidFill>
                 <a:latin typeface="Malgun Gothic"/>
               </a:rPr>
-              <a:t>Smoke 응답</a:t>
-            </a:r>
-          </a:p>
-        </p:txBody>
-      </p:sp>
-      <p:sp>
-        <p:nvSpPr>
-          <p:cNvPr id="17" name="TextBox 16"/>
-          <p:cNvSpPr txBox="1"/>
-          <p:nvPr/>
-        </p:nvSpPr>
-        <p:spPr>
-          <a:xfrm>
-            <a:off x="987552" y="4160520"/>
-            <a:ext cx="9884664" cy="905255"/>
-          </a:xfrm>
-          <a:prstGeom prst="rect">
-            <a:avLst/>
-          </a:prstGeom>
-          <a:noFill/>
-        </p:spPr>
-        <p:txBody>
-          <a:bodyPr wrap="square">
-            <a:spAutoFit/>
-          </a:bodyPr>
-          <a:lstStyle/>
-          <a:p>
-            <a:r>
-              <a:rPr sz="1000" b="0">
+              <a:t>LLM 응답 발췌</a:t>
+            </a:r>
+          </a:p>
+        </p:txBody>
+      </p:sp>
+      <p:sp>
+        <p:nvSpPr>
+          <p:cNvPr id="21" name="TextBox 20"/>
+          <p:cNvSpPr txBox="1"/>
+          <p:nvPr/>
+        </p:nvSpPr>
+        <p:spPr>
+          <a:xfrm>
+            <a:off x="6245352" y="3840480"/>
+            <a:ext cx="4626864" cy="539496"/>
+          </a:xfrm>
+          <a:prstGeom prst="rect">
+            <a:avLst/>
+          </a:prstGeom>
+          <a:noFill/>
+        </p:spPr>
+        <p:txBody>
+          <a:bodyPr wrap="square">
+            <a:spAutoFit/>
+          </a:bodyPr>
+          <a:lstStyle/>
+          <a:p>
+            <a:r>
+              <a:rPr sz="900" b="0">
                 <a:solidFill>
                   <a:srgbClr val="1C2128"/>
                 </a:solidFill>
                 <a:latin typeface="Malgun Gothic"/>
               </a:rPr>
-              <a:t>제시해주신 PoC 실행 결과(PoC evidence run)를 바탕으로, 설계된 AI Native Workflow의 핵심 가치를 관통하는 검증 요약 문장입니다.</a:t>
+              <a:t>SK하이닉스 BoI Wiki PoC의 AI Native Workflow 설계자로서, 제공된 Event 데이터를 분석하여 작성한 **Private BoI(Business Operations Intelligence) 초안 실행 요약**입니다.</a:t>
             </a:r>
             <a:br/>
             <a:br/>
             <a:r>
-              <a:t>**[BoI Wiki PoC 검증 결과 요약]**</a:t>
+              <a:t>---</a:t>
             </a:r>
             <a:br/>
             <a:br/>
             <a:r>
-              <a:t>"본 PoC는 파편화된 업무 맥락의 자산화를 기반으로 Event Broker를 통한 자동화 트리거와 Action Gateway를 활용한 고위험 액션 통제 메커니즘을 구현하였으며, 데이터 신뢰도 및 재사용성 기준에 따른 Private BoI의 Team BoI 승격 프로세스가 AI Native 워크플로우로서 유효함을 입증하였습니다."</a:t>
-            </a:r>
-          </a:p>
-        </p:txBody>
-      </p:sp>
-      <p:sp>
-        <p:nvSpPr>
-          <p:cNvPr id="18" name="TextBox 17"/>
+              <a:t># [Private BoI 초안] Response Chain 이상 발생에 따른 대응 및 지식 자산화</a:t>
+            </a:r>
+            <a:br/>
+            <a:r>
+              <a:t>**대상 장비:** ETCH-VM-01 | **관련 Trace ID:** `trace-492cf5507241492abd6a7160ad14d1d5`</a:t>
+            </a:r>
+            <a:br/>
+            <a:br/>
+            <a:r>
+              <a:t>## 1. 개요 (Executive S</a:t>
+            </a:r>
+          </a:p>
+        </p:txBody>
+      </p:sp>
+      <p:sp>
+        <p:nvSpPr>
+          <p:cNvPr id="22" name="TextBox 21"/>
           <p:cNvSpPr txBox="1"/>
           <p:nvPr/>
         </p:nvSpPr>
@@ -15600,7 +15773,7 @@
       </p:sp>
       <p:sp>
         <p:nvSpPr>
-          <p:cNvPr id="19" name="TextBox 18"/>
+          <p:cNvPr id="23" name="TextBox 22"/>
           <p:cNvSpPr txBox="1"/>
           <p:nvPr/>
         </p:nvSpPr>

</xml_diff>